<commit_message>
feat(presentation): update SIH year to 2026, embed official bulb logo and real app photos for Team atom(x)
</commit_message>
<xml_diff>
--- a/VayuCoupler_SIH_AtomX_Idea_Submission.pptx
+++ b/VayuCoupler_SIH_AtomX_Idea_Submission.pptx
@@ -3132,7 +3132,7 @@
               </a:defRPr>
             </a:pPr>
             <a:r>
-              <a:t>SMART INDIA HACKATHON 2025</a:t>
+              <a:t>SMART INDIA HACKATHON 2026</a:t>
             </a:r>
           </a:p>
         </p:txBody>
@@ -3179,7 +3179,7 @@
       </p:sp>
       <p:pic>
         <p:nvPicPr>
-          <p:cNvPr id="4" name="Picture 3" descr="sih_header_logo.png"/>
+          <p:cNvPr id="4" name="Picture 3" descr="sih_header_logo_2026.png"/>
           <p:cNvPicPr>
             <a:picLocks noChangeAspect="1"/>
           </p:cNvPicPr>
@@ -3193,8 +3193,8 @@
         </p:blipFill>
         <p:spPr>
           <a:xfrm>
-            <a:off x="9875520" y="274320"/>
-            <a:ext cx="1920240" cy="704088"/>
+            <a:off x="9875520" y="228600"/>
+            <a:ext cx="1920240" cy="660082"/>
           </a:xfrm>
           <a:prstGeom prst="rect">
             <a:avLst/>
@@ -3203,7 +3203,7 @@
       </p:pic>
       <p:pic>
         <p:nvPicPr>
-          <p:cNvPr id="5" name="Picture 4" descr="sih_bulb_hero.png"/>
+          <p:cNvPr id="5" name="Picture 4" descr="sih_bulb_official.png"/>
           <p:cNvPicPr>
             <a:picLocks noChangeAspect="1"/>
           </p:cNvPicPr>
@@ -3217,8 +3217,8 @@
         </p:blipFill>
         <p:spPr>
           <a:xfrm>
-            <a:off x="7132320" y="2011680"/>
-            <a:ext cx="4114800" cy="4114800"/>
+            <a:off x="7315200" y="1920240"/>
+            <a:ext cx="4023360" cy="4023360"/>
           </a:xfrm>
           <a:prstGeom prst="rect">
             <a:avLst/>
@@ -3518,7 +3518,7 @@
       </p:sp>
       <p:pic>
         <p:nvPicPr>
-          <p:cNvPr id="4" name="Picture 3" descr="sih_header_logo.png"/>
+          <p:cNvPr id="4" name="Picture 3" descr="sih_header_logo_2026.png"/>
           <p:cNvPicPr>
             <a:picLocks noChangeAspect="1"/>
           </p:cNvPicPr>
@@ -3532,8 +3532,8 @@
         </p:blipFill>
         <p:spPr>
           <a:xfrm>
-            <a:off x="9875520" y="201168"/>
-            <a:ext cx="1920240" cy="704088"/>
+            <a:off x="9875520" y="182880"/>
+            <a:ext cx="1920240" cy="660082"/>
           </a:xfrm>
           <a:prstGeom prst="rect">
             <a:avLst/>
@@ -3621,7 +3621,7 @@
         <p:spPr>
           <a:xfrm>
             <a:off x="457200" y="1051560"/>
-            <a:ext cx="5577840" cy="4206240"/>
+            <a:ext cx="5486400" cy="4206240"/>
           </a:xfrm>
           <a:prstGeom prst="rect">
             <a:avLst/>
@@ -3760,7 +3760,7 @@
       </p:sp>
       <p:pic>
         <p:nvPicPr>
-          <p:cNvPr id="8" name="Picture 7" descr="phone_mockup.png"/>
+          <p:cNvPr id="8" name="Picture 7" descr="framed_real_mobile.png"/>
           <p:cNvPicPr>
             <a:picLocks noChangeAspect="1"/>
           </p:cNvPicPr>
@@ -3774,8 +3774,8 @@
         </p:blipFill>
         <p:spPr>
           <a:xfrm>
-            <a:off x="6217920" y="1097280"/>
-            <a:ext cx="2351314" cy="4114800"/>
+            <a:off x="6172200" y="1051560"/>
+            <a:ext cx="2331720" cy="4451465"/>
           </a:xfrm>
           <a:prstGeom prst="rect">
             <a:avLst/>
@@ -4390,7 +4390,7 @@
       </p:sp>
       <p:pic>
         <p:nvPicPr>
-          <p:cNvPr id="4" name="Picture 3" descr="sih_header_logo.png"/>
+          <p:cNvPr id="4" name="Picture 3" descr="sih_header_logo_2026.png"/>
           <p:cNvPicPr>
             <a:picLocks noChangeAspect="1"/>
           </p:cNvPicPr>
@@ -4404,8 +4404,8 @@
         </p:blipFill>
         <p:spPr>
           <a:xfrm>
-            <a:off x="9875520" y="201168"/>
-            <a:ext cx="1920240" cy="704088"/>
+            <a:off x="9875520" y="182880"/>
+            <a:ext cx="1920240" cy="660082"/>
           </a:xfrm>
           <a:prstGeom prst="rect">
             <a:avLst/>
@@ -4754,7 +4754,7 @@
       </p:sp>
       <p:pic>
         <p:nvPicPr>
-          <p:cNvPr id="11" name="Picture 10" descr="architecture_flow.png"/>
+          <p:cNvPr id="11" name="Picture 10" descr="technical_center_composition.png"/>
           <p:cNvPicPr>
             <a:picLocks noChangeAspect="1"/>
           </p:cNvPicPr>
@@ -4768,8 +4768,8 @@
         </p:blipFill>
         <p:spPr>
           <a:xfrm>
-            <a:off x="3108960" y="1097280"/>
-            <a:ext cx="5852160" cy="4535424"/>
+            <a:off x="3063240" y="1078992"/>
+            <a:ext cx="5943600" cy="4754880"/>
           </a:xfrm>
           <a:prstGeom prst="rect">
             <a:avLst/>
@@ -5167,7 +5167,7 @@
       </p:sp>
       <p:pic>
         <p:nvPicPr>
-          <p:cNvPr id="4" name="Picture 3" descr="sih_header_logo.png"/>
+          <p:cNvPr id="4" name="Picture 3" descr="sih_header_logo_2026.png"/>
           <p:cNvPicPr>
             <a:picLocks noChangeAspect="1"/>
           </p:cNvPicPr>
@@ -5181,8 +5181,8 @@
         </p:blipFill>
         <p:spPr>
           <a:xfrm>
-            <a:off x="9875520" y="201168"/>
-            <a:ext cx="1920240" cy="704088"/>
+            <a:off x="9875520" y="182880"/>
+            <a:ext cx="1920240" cy="660082"/>
           </a:xfrm>
           <a:prstGeom prst="rect">
             <a:avLst/>
@@ -5757,7 +5757,7 @@
       </p:sp>
       <p:pic>
         <p:nvPicPr>
-          <p:cNvPr id="4" name="Picture 3" descr="sih_header_logo.png"/>
+          <p:cNvPr id="4" name="Picture 3" descr="sih_header_logo_2026.png"/>
           <p:cNvPicPr>
             <a:picLocks noChangeAspect="1"/>
           </p:cNvPicPr>
@@ -5771,8 +5771,8 @@
         </p:blipFill>
         <p:spPr>
           <a:xfrm>
-            <a:off x="9875520" y="201168"/>
-            <a:ext cx="1920240" cy="704088"/>
+            <a:off x="9875520" y="182880"/>
+            <a:ext cx="1920240" cy="660082"/>
           </a:xfrm>
           <a:prstGeom prst="rect">
             <a:avLst/>
@@ -5860,7 +5860,7 @@
         <p:spPr>
           <a:xfrm>
             <a:off x="548640" y="1051560"/>
-            <a:ext cx="5852160" cy="5120640"/>
+            <a:ext cx="5669280" cy="5120640"/>
           </a:xfrm>
           <a:prstGeom prst="rect">
             <a:avLst/>
@@ -5999,8 +5999,8 @@
         </p:nvSpPr>
         <p:spPr>
           <a:xfrm>
-            <a:off x="6675120" y="1097280"/>
-            <a:ext cx="5029200" cy="502920"/>
+            <a:off x="6492240" y="1097280"/>
+            <a:ext cx="5212080" cy="502920"/>
           </a:xfrm>
           <a:prstGeom prst="roundRect">
             <a:avLst/>
@@ -6048,7 +6048,7 @@
       </p:sp>
       <p:pic>
         <p:nvPicPr>
-          <p:cNvPr id="9" name="Picture 8" descr="command_center_preview.png"/>
+          <p:cNvPr id="9" name="Picture 8" descr="real_app_desktop.png"/>
           <p:cNvPicPr>
             <a:picLocks noChangeAspect="1"/>
           </p:cNvPicPr>
@@ -6062,8 +6062,8 @@
         </p:blipFill>
         <p:spPr>
           <a:xfrm>
-            <a:off x="6675120" y="1737360"/>
-            <a:ext cx="5029200" cy="3520440"/>
+            <a:off x="6492240" y="1737360"/>
+            <a:ext cx="5212080" cy="3164477"/>
           </a:xfrm>
           <a:prstGeom prst="rect">
             <a:avLst/>
@@ -6189,7 +6189,7 @@
       </p:sp>
       <p:pic>
         <p:nvPicPr>
-          <p:cNvPr id="4" name="Picture 3" descr="sih_header_logo.png"/>
+          <p:cNvPr id="4" name="Picture 3" descr="sih_header_logo_2026.png"/>
           <p:cNvPicPr>
             <a:picLocks noChangeAspect="1"/>
           </p:cNvPicPr>
@@ -6203,8 +6203,8 @@
         </p:blipFill>
         <p:spPr>
           <a:xfrm>
-            <a:off x="9875520" y="201168"/>
-            <a:ext cx="1920240" cy="704088"/>
+            <a:off x="9875520" y="182880"/>
+            <a:ext cx="1920240" cy="660082"/>
           </a:xfrm>
           <a:prstGeom prst="rect">
             <a:avLst/>

</xml_diff>

<commit_message>
feat(commute): add weather tab next to home, google maps route navigation, clean vehicle modes, and dynamic diurnal departure clock
</commit_message>
<xml_diff>
--- a/VayuCoupler_SIH_AtomX_Idea_Submission.pptx
+++ b/VayuCoupler_SIH_AtomX_Idea_Submission.pptx
@@ -5,14 +5,14 @@
     <p:sldMasterId id="2147483648" r:id="rId1"/>
   </p:sldMasterIdLst>
   <p:sldIdLst>
-    <p:sldId id="256" r:id="rId7"/>
-    <p:sldId id="257" r:id="rId8"/>
-    <p:sldId id="258" r:id="rId9"/>
-    <p:sldId id="259" r:id="rId10"/>
-    <p:sldId id="260" r:id="rId11"/>
-    <p:sldId id="261" r:id="rId12"/>
+    <p:sldId id="256" r:id="rId2"/>
+    <p:sldId id="257" r:id="rId3"/>
+    <p:sldId id="258" r:id="rId4"/>
+    <p:sldId id="259" r:id="rId5"/>
+    <p:sldId id="260" r:id="rId6"/>
+    <p:sldId id="261" r:id="rId7"/>
   </p:sldIdLst>
-  <p:sldSz cx="12191695" cy="6858000" type="screen4x3"/>
+  <p:sldSz cx="12192000" cy="6858000"/>
   <p:notesSz cx="6858000" cy="9144000"/>
   <p:defaultTextStyle>
     <a:defPPr>
@@ -109,6 +109,22 @@
       </a:defRPr>
     </a:lvl9pPr>
   </p:defaultTextStyle>
+  <p:extLst>
+    <p:ext uri="{EFAFB233-063F-42B5-8137-9DF3F51BA10A}">
+      <p15:sldGuideLst xmlns:p15="http://schemas.microsoft.com/office/powerpoint/2012/main">
+        <p15:guide id="1" orient="horz" pos="2160">
+          <p15:clr>
+            <a:srgbClr val="A4A3A4"/>
+          </p15:clr>
+        </p15:guide>
+        <p15:guide id="2" pos="2880">
+          <p15:clr>
+            <a:srgbClr val="A4A3A4"/>
+          </p15:clr>
+        </p15:guide>
+      </p15:sldGuideLst>
+    </p:ext>
+  </p:extLst>
 </p:presentation>
 </file>
 
@@ -150,10 +166,9 @@
           <a:lstStyle/>
           <a:p>
             <a:r>
-              <a:rPr lang="en-US" smtClean="0"/>
+              <a:rPr lang="en-US"/>
               <a:t>Click to edit Master title style</a:t>
             </a:r>
-            <a:endParaRPr lang="en-US"/>
           </a:p>
         </p:txBody>
       </p:sp>
@@ -269,10 +284,9 @@
           </a:lstStyle>
           <a:p>
             <a:r>
-              <a:rPr lang="en-US" smtClean="0"/>
+              <a:rPr lang="en-US"/>
               <a:t>Click to edit Master subtitle style</a:t>
             </a:r>
-            <a:endParaRPr lang="en-US"/>
           </a:p>
         </p:txBody>
       </p:sp>
@@ -293,7 +307,7 @@
           <a:p>
             <a:fld id="{5BCAD085-E8A6-8845-BD4E-CB4CCA059FC4}" type="datetimeFigureOut">
               <a:rPr lang="en-US" smtClean="0"/>
-              <a:t>1/27/13</a:t>
+              <a:t>9/10/2026</a:t>
             </a:fld>
             <a:endParaRPr lang="en-US"/>
           </a:p>
@@ -387,10 +401,9 @@
           <a:lstStyle/>
           <a:p>
             <a:r>
-              <a:rPr lang="en-US" smtClean="0"/>
+              <a:rPr lang="en-US"/>
               <a:t>Click to edit Master title style</a:t>
             </a:r>
-            <a:endParaRPr lang="en-US"/>
           </a:p>
         </p:txBody>
       </p:sp>
@@ -411,38 +424,37 @@
           <a:p>
             <a:pPr lvl="0"/>
             <a:r>
-              <a:rPr lang="en-US" smtClean="0"/>
+              <a:rPr lang="en-US"/>
               <a:t>Click to edit Master text styles</a:t>
             </a:r>
           </a:p>
           <a:p>
             <a:pPr lvl="1"/>
             <a:r>
-              <a:rPr lang="en-US" smtClean="0"/>
+              <a:rPr lang="en-US"/>
               <a:t>Second level</a:t>
             </a:r>
           </a:p>
           <a:p>
             <a:pPr lvl="2"/>
             <a:r>
-              <a:rPr lang="en-US" smtClean="0"/>
+              <a:rPr lang="en-US"/>
               <a:t>Third level</a:t>
             </a:r>
           </a:p>
           <a:p>
             <a:pPr lvl="3"/>
             <a:r>
-              <a:rPr lang="en-US" smtClean="0"/>
+              <a:rPr lang="en-US"/>
               <a:t>Fourth level</a:t>
             </a:r>
           </a:p>
           <a:p>
             <a:pPr lvl="4"/>
             <a:r>
-              <a:rPr lang="en-US" smtClean="0"/>
+              <a:rPr lang="en-US"/>
               <a:t>Fifth level</a:t>
             </a:r>
-            <a:endParaRPr lang="en-US"/>
           </a:p>
         </p:txBody>
       </p:sp>
@@ -463,7 +475,7 @@
           <a:p>
             <a:fld id="{5BCAD085-E8A6-8845-BD4E-CB4CCA059FC4}" type="datetimeFigureOut">
               <a:rPr lang="en-US" smtClean="0"/>
-              <a:t>1/27/13</a:t>
+              <a:t>9/10/2026</a:t>
             </a:fld>
             <a:endParaRPr lang="en-US"/>
           </a:p>
@@ -562,10 +574,9 @@
           <a:lstStyle/>
           <a:p>
             <a:r>
-              <a:rPr lang="en-US" smtClean="0"/>
+              <a:rPr lang="en-US"/>
               <a:t>Click to edit Master title style</a:t>
             </a:r>
-            <a:endParaRPr lang="en-US"/>
           </a:p>
         </p:txBody>
       </p:sp>
@@ -591,38 +602,37 @@
           <a:p>
             <a:pPr lvl="0"/>
             <a:r>
-              <a:rPr lang="en-US" smtClean="0"/>
+              <a:rPr lang="en-US"/>
               <a:t>Click to edit Master text styles</a:t>
             </a:r>
           </a:p>
           <a:p>
             <a:pPr lvl="1"/>
             <a:r>
-              <a:rPr lang="en-US" smtClean="0"/>
+              <a:rPr lang="en-US"/>
               <a:t>Second level</a:t>
             </a:r>
           </a:p>
           <a:p>
             <a:pPr lvl="2"/>
             <a:r>
-              <a:rPr lang="en-US" smtClean="0"/>
+              <a:rPr lang="en-US"/>
               <a:t>Third level</a:t>
             </a:r>
           </a:p>
           <a:p>
             <a:pPr lvl="3"/>
             <a:r>
-              <a:rPr lang="en-US" smtClean="0"/>
+              <a:rPr lang="en-US"/>
               <a:t>Fourth level</a:t>
             </a:r>
           </a:p>
           <a:p>
             <a:pPr lvl="4"/>
             <a:r>
-              <a:rPr lang="en-US" smtClean="0"/>
+              <a:rPr lang="en-US"/>
               <a:t>Fifth level</a:t>
             </a:r>
-            <a:endParaRPr lang="en-US"/>
           </a:p>
         </p:txBody>
       </p:sp>
@@ -643,7 +653,7 @@
           <a:p>
             <a:fld id="{5BCAD085-E8A6-8845-BD4E-CB4CCA059FC4}" type="datetimeFigureOut">
               <a:rPr lang="en-US" smtClean="0"/>
-              <a:t>1/27/13</a:t>
+              <a:t>9/10/2026</a:t>
             </a:fld>
             <a:endParaRPr lang="en-US"/>
           </a:p>
@@ -737,10 +747,9 @@
           <a:lstStyle/>
           <a:p>
             <a:r>
-              <a:rPr lang="en-US" smtClean="0"/>
+              <a:rPr lang="en-US"/>
               <a:t>Click to edit Master title style</a:t>
             </a:r>
-            <a:endParaRPr lang="en-US"/>
           </a:p>
         </p:txBody>
       </p:sp>
@@ -761,38 +770,37 @@
           <a:p>
             <a:pPr lvl="0"/>
             <a:r>
-              <a:rPr lang="en-US" smtClean="0"/>
+              <a:rPr lang="en-US"/>
               <a:t>Click to edit Master text styles</a:t>
             </a:r>
           </a:p>
           <a:p>
             <a:pPr lvl="1"/>
             <a:r>
-              <a:rPr lang="en-US" smtClean="0"/>
+              <a:rPr lang="en-US"/>
               <a:t>Second level</a:t>
             </a:r>
           </a:p>
           <a:p>
             <a:pPr lvl="2"/>
             <a:r>
-              <a:rPr lang="en-US" smtClean="0"/>
+              <a:rPr lang="en-US"/>
               <a:t>Third level</a:t>
             </a:r>
           </a:p>
           <a:p>
             <a:pPr lvl="3"/>
             <a:r>
-              <a:rPr lang="en-US" smtClean="0"/>
+              <a:rPr lang="en-US"/>
               <a:t>Fourth level</a:t>
             </a:r>
           </a:p>
           <a:p>
             <a:pPr lvl="4"/>
             <a:r>
-              <a:rPr lang="en-US" smtClean="0"/>
+              <a:rPr lang="en-US"/>
               <a:t>Fifth level</a:t>
             </a:r>
-            <a:endParaRPr lang="en-US"/>
           </a:p>
         </p:txBody>
       </p:sp>
@@ -813,7 +821,7 @@
           <a:p>
             <a:fld id="{5BCAD085-E8A6-8845-BD4E-CB4CCA059FC4}" type="datetimeFigureOut">
               <a:rPr lang="en-US" smtClean="0"/>
-              <a:t>1/27/13</a:t>
+              <a:t>9/10/2026</a:t>
             </a:fld>
             <a:endParaRPr lang="en-US"/>
           </a:p>
@@ -916,10 +924,9 @@
           </a:lstStyle>
           <a:p>
             <a:r>
-              <a:rPr lang="en-US" smtClean="0"/>
+              <a:rPr lang="en-US"/>
               <a:t>Click to edit Master title style</a:t>
             </a:r>
-            <a:endParaRPr lang="en-US"/>
           </a:p>
         </p:txBody>
       </p:sp>
@@ -1036,7 +1043,7 @@
           <a:p>
             <a:pPr lvl="0"/>
             <a:r>
-              <a:rPr lang="en-US" smtClean="0"/>
+              <a:rPr lang="en-US"/>
               <a:t>Click to edit Master text styles</a:t>
             </a:r>
           </a:p>
@@ -1059,7 +1066,7 @@
           <a:p>
             <a:fld id="{5BCAD085-E8A6-8845-BD4E-CB4CCA059FC4}" type="datetimeFigureOut">
               <a:rPr lang="en-US" smtClean="0"/>
-              <a:t>1/27/13</a:t>
+              <a:t>9/10/2026</a:t>
             </a:fld>
             <a:endParaRPr lang="en-US"/>
           </a:p>
@@ -1153,10 +1160,9 @@
           <a:lstStyle/>
           <a:p>
             <a:r>
-              <a:rPr lang="en-US" smtClean="0"/>
+              <a:rPr lang="en-US"/>
               <a:t>Click to edit Master title style</a:t>
             </a:r>
-            <a:endParaRPr lang="en-US"/>
           </a:p>
         </p:txBody>
       </p:sp>
@@ -1210,38 +1216,37 @@
           <a:p>
             <a:pPr lvl="0"/>
             <a:r>
-              <a:rPr lang="en-US" smtClean="0"/>
+              <a:rPr lang="en-US"/>
               <a:t>Click to edit Master text styles</a:t>
             </a:r>
           </a:p>
           <a:p>
             <a:pPr lvl="1"/>
             <a:r>
-              <a:rPr lang="en-US" smtClean="0"/>
+              <a:rPr lang="en-US"/>
               <a:t>Second level</a:t>
             </a:r>
           </a:p>
           <a:p>
             <a:pPr lvl="2"/>
             <a:r>
-              <a:rPr lang="en-US" smtClean="0"/>
+              <a:rPr lang="en-US"/>
               <a:t>Third level</a:t>
             </a:r>
           </a:p>
           <a:p>
             <a:pPr lvl="3"/>
             <a:r>
-              <a:rPr lang="en-US" smtClean="0"/>
+              <a:rPr lang="en-US"/>
               <a:t>Fourth level</a:t>
             </a:r>
           </a:p>
           <a:p>
             <a:pPr lvl="4"/>
             <a:r>
-              <a:rPr lang="en-US" smtClean="0"/>
+              <a:rPr lang="en-US"/>
               <a:t>Fifth level</a:t>
             </a:r>
-            <a:endParaRPr lang="en-US"/>
           </a:p>
         </p:txBody>
       </p:sp>
@@ -1295,38 +1300,37 @@
           <a:p>
             <a:pPr lvl="0"/>
             <a:r>
-              <a:rPr lang="en-US" smtClean="0"/>
+              <a:rPr lang="en-US"/>
               <a:t>Click to edit Master text styles</a:t>
             </a:r>
           </a:p>
           <a:p>
             <a:pPr lvl="1"/>
             <a:r>
-              <a:rPr lang="en-US" smtClean="0"/>
+              <a:rPr lang="en-US"/>
               <a:t>Second level</a:t>
             </a:r>
           </a:p>
           <a:p>
             <a:pPr lvl="2"/>
             <a:r>
-              <a:rPr lang="en-US" smtClean="0"/>
+              <a:rPr lang="en-US"/>
               <a:t>Third level</a:t>
             </a:r>
           </a:p>
           <a:p>
             <a:pPr lvl="3"/>
             <a:r>
-              <a:rPr lang="en-US" smtClean="0"/>
+              <a:rPr lang="en-US"/>
               <a:t>Fourth level</a:t>
             </a:r>
           </a:p>
           <a:p>
             <a:pPr lvl="4"/>
             <a:r>
-              <a:rPr lang="en-US" smtClean="0"/>
+              <a:rPr lang="en-US"/>
               <a:t>Fifth level</a:t>
             </a:r>
-            <a:endParaRPr lang="en-US"/>
           </a:p>
         </p:txBody>
       </p:sp>
@@ -1347,7 +1351,7 @@
           <a:p>
             <a:fld id="{5BCAD085-E8A6-8845-BD4E-CB4CCA059FC4}" type="datetimeFigureOut">
               <a:rPr lang="en-US" smtClean="0"/>
-              <a:t>1/27/13</a:t>
+              <a:t>9/10/2026</a:t>
             </a:fld>
             <a:endParaRPr lang="en-US"/>
           </a:p>
@@ -1445,10 +1449,9 @@
           </a:lstStyle>
           <a:p>
             <a:r>
-              <a:rPr lang="en-US" smtClean="0"/>
+              <a:rPr lang="en-US"/>
               <a:t>Click to edit Master title style</a:t>
             </a:r>
-            <a:endParaRPr lang="en-US"/>
           </a:p>
         </p:txBody>
       </p:sp>
@@ -1511,7 +1514,7 @@
           <a:p>
             <a:pPr lvl="0"/>
             <a:r>
-              <a:rPr lang="en-US" smtClean="0"/>
+              <a:rPr lang="en-US"/>
               <a:t>Click to edit Master text styles</a:t>
             </a:r>
           </a:p>
@@ -1567,38 +1570,37 @@
           <a:p>
             <a:pPr lvl="0"/>
             <a:r>
-              <a:rPr lang="en-US" smtClean="0"/>
+              <a:rPr lang="en-US"/>
               <a:t>Click to edit Master text styles</a:t>
             </a:r>
           </a:p>
           <a:p>
             <a:pPr lvl="1"/>
             <a:r>
-              <a:rPr lang="en-US" smtClean="0"/>
+              <a:rPr lang="en-US"/>
               <a:t>Second level</a:t>
             </a:r>
           </a:p>
           <a:p>
             <a:pPr lvl="2"/>
             <a:r>
-              <a:rPr lang="en-US" smtClean="0"/>
+              <a:rPr lang="en-US"/>
               <a:t>Third level</a:t>
             </a:r>
           </a:p>
           <a:p>
             <a:pPr lvl="3"/>
             <a:r>
-              <a:rPr lang="en-US" smtClean="0"/>
+              <a:rPr lang="en-US"/>
               <a:t>Fourth level</a:t>
             </a:r>
           </a:p>
           <a:p>
             <a:pPr lvl="4"/>
             <a:r>
-              <a:rPr lang="en-US" smtClean="0"/>
+              <a:rPr lang="en-US"/>
               <a:t>Fifth level</a:t>
             </a:r>
-            <a:endParaRPr lang="en-US"/>
           </a:p>
         </p:txBody>
       </p:sp>
@@ -1661,7 +1663,7 @@
           <a:p>
             <a:pPr lvl="0"/>
             <a:r>
-              <a:rPr lang="en-US" smtClean="0"/>
+              <a:rPr lang="en-US"/>
               <a:t>Click to edit Master text styles</a:t>
             </a:r>
           </a:p>
@@ -1717,38 +1719,37 @@
           <a:p>
             <a:pPr lvl="0"/>
             <a:r>
-              <a:rPr lang="en-US" smtClean="0"/>
+              <a:rPr lang="en-US"/>
               <a:t>Click to edit Master text styles</a:t>
             </a:r>
           </a:p>
           <a:p>
             <a:pPr lvl="1"/>
             <a:r>
-              <a:rPr lang="en-US" smtClean="0"/>
+              <a:rPr lang="en-US"/>
               <a:t>Second level</a:t>
             </a:r>
           </a:p>
           <a:p>
             <a:pPr lvl="2"/>
             <a:r>
-              <a:rPr lang="en-US" smtClean="0"/>
+              <a:rPr lang="en-US"/>
               <a:t>Third level</a:t>
             </a:r>
           </a:p>
           <a:p>
             <a:pPr lvl="3"/>
             <a:r>
-              <a:rPr lang="en-US" smtClean="0"/>
+              <a:rPr lang="en-US"/>
               <a:t>Fourth level</a:t>
             </a:r>
           </a:p>
           <a:p>
             <a:pPr lvl="4"/>
             <a:r>
-              <a:rPr lang="en-US" smtClean="0"/>
+              <a:rPr lang="en-US"/>
               <a:t>Fifth level</a:t>
             </a:r>
-            <a:endParaRPr lang="en-US"/>
           </a:p>
         </p:txBody>
       </p:sp>
@@ -1769,7 +1770,7 @@
           <a:p>
             <a:fld id="{5BCAD085-E8A6-8845-BD4E-CB4CCA059FC4}" type="datetimeFigureOut">
               <a:rPr lang="en-US" smtClean="0"/>
-              <a:t>1/27/13</a:t>
+              <a:t>9/10/2026</a:t>
             </a:fld>
             <a:endParaRPr lang="en-US"/>
           </a:p>
@@ -1863,10 +1864,9 @@
           <a:lstStyle/>
           <a:p>
             <a:r>
-              <a:rPr lang="en-US" smtClean="0"/>
+              <a:rPr lang="en-US"/>
               <a:t>Click to edit Master title style</a:t>
             </a:r>
-            <a:endParaRPr lang="en-US"/>
           </a:p>
         </p:txBody>
       </p:sp>
@@ -1887,7 +1887,7 @@
           <a:p>
             <a:fld id="{5BCAD085-E8A6-8845-BD4E-CB4CCA059FC4}" type="datetimeFigureOut">
               <a:rPr lang="en-US" smtClean="0"/>
-              <a:t>1/27/13</a:t>
+              <a:t>9/10/2026</a:t>
             </a:fld>
             <a:endParaRPr lang="en-US"/>
           </a:p>
@@ -1982,7 +1982,7 @@
           <a:p>
             <a:fld id="{5BCAD085-E8A6-8845-BD4E-CB4CCA059FC4}" type="datetimeFigureOut">
               <a:rPr lang="en-US" smtClean="0"/>
-              <a:t>1/27/13</a:t>
+              <a:t>9/10/2026</a:t>
             </a:fld>
             <a:endParaRPr lang="en-US"/>
           </a:p>
@@ -2085,10 +2085,9 @@
           </a:lstStyle>
           <a:p>
             <a:r>
-              <a:rPr lang="en-US" smtClean="0"/>
+              <a:rPr lang="en-US"/>
               <a:t>Click to edit Master title style</a:t>
             </a:r>
-            <a:endParaRPr lang="en-US"/>
           </a:p>
         </p:txBody>
       </p:sp>
@@ -2142,38 +2141,37 @@
           <a:p>
             <a:pPr lvl="0"/>
             <a:r>
-              <a:rPr lang="en-US" smtClean="0"/>
+              <a:rPr lang="en-US"/>
               <a:t>Click to edit Master text styles</a:t>
             </a:r>
           </a:p>
           <a:p>
             <a:pPr lvl="1"/>
             <a:r>
-              <a:rPr lang="en-US" smtClean="0"/>
+              <a:rPr lang="en-US"/>
               <a:t>Second level</a:t>
             </a:r>
           </a:p>
           <a:p>
             <a:pPr lvl="2"/>
             <a:r>
-              <a:rPr lang="en-US" smtClean="0"/>
+              <a:rPr lang="en-US"/>
               <a:t>Third level</a:t>
             </a:r>
           </a:p>
           <a:p>
             <a:pPr lvl="3"/>
             <a:r>
-              <a:rPr lang="en-US" smtClean="0"/>
+              <a:rPr lang="en-US"/>
               <a:t>Fourth level</a:t>
             </a:r>
           </a:p>
           <a:p>
             <a:pPr lvl="4"/>
             <a:r>
-              <a:rPr lang="en-US" smtClean="0"/>
+              <a:rPr lang="en-US"/>
               <a:t>Fifth level</a:t>
             </a:r>
-            <a:endParaRPr lang="en-US"/>
           </a:p>
         </p:txBody>
       </p:sp>
@@ -2236,7 +2234,7 @@
           <a:p>
             <a:pPr lvl="0"/>
             <a:r>
-              <a:rPr lang="en-US" smtClean="0"/>
+              <a:rPr lang="en-US"/>
               <a:t>Click to edit Master text styles</a:t>
             </a:r>
           </a:p>
@@ -2259,7 +2257,7 @@
           <a:p>
             <a:fld id="{5BCAD085-E8A6-8845-BD4E-CB4CCA059FC4}" type="datetimeFigureOut">
               <a:rPr lang="en-US" smtClean="0"/>
-              <a:t>1/27/13</a:t>
+              <a:t>9/10/2026</a:t>
             </a:fld>
             <a:endParaRPr lang="en-US"/>
           </a:p>
@@ -2362,10 +2360,9 @@
           </a:lstStyle>
           <a:p>
             <a:r>
-              <a:rPr lang="en-US" smtClean="0"/>
+              <a:rPr lang="en-US"/>
               <a:t>Click to edit Master title style</a:t>
             </a:r>
-            <a:endParaRPr lang="en-US"/>
           </a:p>
         </p:txBody>
       </p:sp>
@@ -2489,7 +2486,7 @@
           <a:p>
             <a:pPr lvl="0"/>
             <a:r>
-              <a:rPr lang="en-US" smtClean="0"/>
+              <a:rPr lang="en-US"/>
               <a:t>Click to edit Master text styles</a:t>
             </a:r>
           </a:p>
@@ -2512,7 +2509,7 @@
           <a:p>
             <a:fld id="{5BCAD085-E8A6-8845-BD4E-CB4CCA059FC4}" type="datetimeFigureOut">
               <a:rPr lang="en-US" smtClean="0"/>
-              <a:t>1/27/13</a:t>
+              <a:t>9/10/2026</a:t>
             </a:fld>
             <a:endParaRPr lang="en-US"/>
           </a:p>
@@ -2621,10 +2618,9 @@
           <a:lstStyle/>
           <a:p>
             <a:r>
-              <a:rPr lang="en-US" smtClean="0"/>
+              <a:rPr lang="en-US"/>
               <a:t>Click to edit Master title style</a:t>
             </a:r>
-            <a:endParaRPr lang="en-US"/>
           </a:p>
         </p:txBody>
       </p:sp>
@@ -2655,38 +2651,37 @@
           <a:p>
             <a:pPr lvl="0"/>
             <a:r>
-              <a:rPr lang="en-US" smtClean="0"/>
+              <a:rPr lang="en-US"/>
               <a:t>Click to edit Master text styles</a:t>
             </a:r>
           </a:p>
           <a:p>
             <a:pPr lvl="1"/>
             <a:r>
-              <a:rPr lang="en-US" smtClean="0"/>
+              <a:rPr lang="en-US"/>
               <a:t>Second level</a:t>
             </a:r>
           </a:p>
           <a:p>
             <a:pPr lvl="2"/>
             <a:r>
-              <a:rPr lang="en-US" smtClean="0"/>
+              <a:rPr lang="en-US"/>
               <a:t>Third level</a:t>
             </a:r>
           </a:p>
           <a:p>
             <a:pPr lvl="3"/>
             <a:r>
-              <a:rPr lang="en-US" smtClean="0"/>
+              <a:rPr lang="en-US"/>
               <a:t>Fourth level</a:t>
             </a:r>
           </a:p>
           <a:p>
             <a:pPr lvl="4"/>
             <a:r>
-              <a:rPr lang="en-US" smtClean="0"/>
+              <a:rPr lang="en-US"/>
               <a:t>Fifth level</a:t>
             </a:r>
-            <a:endParaRPr lang="en-US"/>
           </a:p>
         </p:txBody>
       </p:sp>
@@ -2725,7 +2720,7 @@
           <a:p>
             <a:fld id="{5BCAD085-E8A6-8845-BD4E-CB4CCA059FC4}" type="datetimeFigureOut">
               <a:rPr lang="en-US" smtClean="0"/>
-              <a:t>1/27/13</a:t>
+              <a:t>9/10/2026</a:t>
             </a:fld>
             <a:endParaRPr lang="en-US"/>
           </a:p>
@@ -3084,7 +3079,7 @@
 </file>
 
 <file path=ppt/slides/slide1.xml><?xml version="1.0" encoding="utf-8"?>
-<p:sld xmlns:a="http://schemas.openxmlformats.org/drawingml/2006/main" xmlns:p="http://schemas.openxmlformats.org/presentationml/2006/main" xmlns:r="http://schemas.openxmlformats.org/officeDocument/2006/relationships">
+<p:sld xmlns:a="http://schemas.openxmlformats.org/drawingml/2006/main" xmlns:r="http://schemas.openxmlformats.org/officeDocument/2006/relationships" xmlns:p="http://schemas.openxmlformats.org/presentationml/2006/main">
   <p:cSld>
     <p:bg>
       <p:bgPr>
@@ -3100,7 +3095,14 @@
         <p:cNvGrpSpPr/>
         <p:nvPr/>
       </p:nvGrpSpPr>
-      <p:grpSpPr/>
+      <p:grpSpPr>
+        <a:xfrm>
+          <a:off x="0" y="0"/>
+          <a:ext cx="0" cy="0"/>
+          <a:chOff x="0" y="0"/>
+          <a:chExt cx="0" cy="0"/>
+        </a:xfrm>
+      </p:grpSpPr>
       <p:sp>
         <p:nvSpPr>
           <p:cNvPr id="2" name="TextBox 1"/>
@@ -3234,7 +3236,7 @@
         <p:spPr>
           <a:xfrm>
             <a:off x="731520" y="2103120"/>
-            <a:ext cx="6217920" cy="4114800"/>
+            <a:ext cx="6217920" cy="2877711"/>
           </a:xfrm>
           <a:prstGeom prst="rect">
             <a:avLst/>
@@ -3253,7 +3255,7 @@
               </a:spcAft>
             </a:pPr>
             <a:r>
-              <a:rPr sz="1600" b="1">
+              <a:rPr sz="1600" b="1" dirty="0">
                 <a:solidFill>
                   <a:srgbClr val="111827"/>
                 </a:solidFill>
@@ -3262,7 +3264,7 @@
               <a:t>Problem Statement ID –</a:t>
             </a:r>
             <a:r>
-              <a:rPr sz="1500" b="0">
+              <a:rPr sz="1500" b="0" dirty="0">
                 <a:solidFill>
                   <a:srgbClr val="111827"/>
                 </a:solidFill>
@@ -3278,7 +3280,7 @@
               </a:spcAft>
             </a:pPr>
             <a:r>
-              <a:rPr sz="1600" b="1">
+              <a:rPr sz="1600" b="1" dirty="0">
                 <a:solidFill>
                   <a:srgbClr val="111827"/>
                 </a:solidFill>
@@ -3287,7 +3289,7 @@
               <a:t>Problem Statement Title-</a:t>
             </a:r>
             <a:r>
-              <a:rPr sz="1500" b="0">
+              <a:rPr sz="1500" b="0" dirty="0">
                 <a:solidFill>
                   <a:srgbClr val="111827"/>
                 </a:solidFill>
@@ -3304,7 +3306,7 @@
               </a:spcAft>
             </a:pPr>
             <a:r>
-              <a:rPr sz="1600" b="1">
+              <a:rPr sz="1600" b="1" dirty="0">
                 <a:solidFill>
                   <a:srgbClr val="111827"/>
                 </a:solidFill>
@@ -3313,7 +3315,7 @@
               <a:t>Theme-</a:t>
             </a:r>
             <a:r>
-              <a:rPr sz="1500" b="0">
+              <a:rPr sz="1500" b="0" dirty="0">
                 <a:solidFill>
                   <a:srgbClr val="111827"/>
                 </a:solidFill>
@@ -3329,7 +3331,7 @@
               </a:spcAft>
             </a:pPr>
             <a:r>
-              <a:rPr sz="1600" b="1">
+              <a:rPr sz="1600" b="1" dirty="0">
                 <a:solidFill>
                   <a:srgbClr val="111827"/>
                 </a:solidFill>
@@ -3338,7 +3340,7 @@
               <a:t>PS Category-</a:t>
             </a:r>
             <a:r>
-              <a:rPr sz="1500" b="0">
+              <a:rPr sz="1500" b="0" dirty="0">
                 <a:solidFill>
                   <a:srgbClr val="111827"/>
                 </a:solidFill>
@@ -3354,7 +3356,7 @@
               </a:spcAft>
             </a:pPr>
             <a:r>
-              <a:rPr sz="1600" b="1">
+              <a:rPr sz="1600" b="1" dirty="0">
                 <a:solidFill>
                   <a:srgbClr val="111827"/>
                 </a:solidFill>
@@ -3363,7 +3365,7 @@
               <a:t>Team ID-</a:t>
             </a:r>
             <a:r>
-              <a:rPr sz="1500" b="0">
+              <a:rPr sz="1500" b="0" dirty="0">
                 <a:solidFill>
                   <a:srgbClr val="111827"/>
                 </a:solidFill>
@@ -3379,7 +3381,7 @@
               </a:spcAft>
             </a:pPr>
             <a:r>
-              <a:rPr sz="1600" b="1">
+              <a:rPr sz="1600" b="1" dirty="0">
                 <a:solidFill>
                   <a:srgbClr val="111827"/>
                 </a:solidFill>
@@ -3388,14 +3390,47 @@
               <a:t>Team Name (Registered on portal)-</a:t>
             </a:r>
             <a:r>
-              <a:rPr sz="1500" b="0">
+              <a:rPr sz="1500" b="0" dirty="0">
                 <a:solidFill>
                   <a:srgbClr val="111827"/>
                 </a:solidFill>
                 <a:latin typeface="Arial"/>
               </a:rPr>
-              <a:t> atom(x)</a:t>
-            </a:r>
+              <a:t> </a:t>
+            </a:r>
+            <a:r>
+              <a:rPr lang="en-US" sz="1500" b="0" dirty="0" err="1">
+                <a:solidFill>
+                  <a:srgbClr val="111827"/>
+                </a:solidFill>
+                <a:latin typeface="Arial"/>
+              </a:rPr>
+              <a:t>A</a:t>
+            </a:r>
+            <a:r>
+              <a:rPr sz="1500" b="0" dirty="0" err="1">
+                <a:solidFill>
+                  <a:srgbClr val="111827"/>
+                </a:solidFill>
+                <a:latin typeface="Arial"/>
+              </a:rPr>
+              <a:t>tom</a:t>
+            </a:r>
+            <a:r>
+              <a:rPr lang="en-US" sz="1500" dirty="0" err="1">
+                <a:solidFill>
+                  <a:srgbClr val="111827"/>
+                </a:solidFill>
+                <a:latin typeface="Arial"/>
+              </a:rPr>
+              <a:t>X</a:t>
+            </a:r>
+            <a:endParaRPr sz="1500" b="0" dirty="0">
+              <a:solidFill>
+                <a:srgbClr val="111827"/>
+              </a:solidFill>
+              <a:latin typeface="Arial"/>
+            </a:endParaRPr>
           </a:p>
         </p:txBody>
       </p:sp>
@@ -3408,7 +3443,7 @@
 </file>
 
 <file path=ppt/slides/slide2.xml><?xml version="1.0" encoding="utf-8"?>
-<p:sld xmlns:a="http://schemas.openxmlformats.org/drawingml/2006/main" xmlns:p="http://schemas.openxmlformats.org/presentationml/2006/main" xmlns:r="http://schemas.openxmlformats.org/officeDocument/2006/relationships">
+<p:sld xmlns:a="http://schemas.openxmlformats.org/drawingml/2006/main" xmlns:r="http://schemas.openxmlformats.org/officeDocument/2006/relationships" xmlns:p="http://schemas.openxmlformats.org/presentationml/2006/main">
   <p:cSld>
     <p:bg>
       <p:bgPr>
@@ -3424,7 +3459,14 @@
         <p:cNvGrpSpPr/>
         <p:nvPr/>
       </p:nvGrpSpPr>
-      <p:grpSpPr/>
+      <p:grpSpPr>
+        <a:xfrm>
+          <a:off x="0" y="0"/>
+          <a:ext cx="0" cy="0"/>
+          <a:chOff x="0" y="0"/>
+          <a:chExt cx="0" cy="0"/>
+        </a:xfrm>
+      </p:grpSpPr>
       <p:sp>
         <p:nvSpPr>
           <p:cNvPr id="2" name="Rounded Rectangle 1"/>
@@ -3463,7 +3505,7 @@
           </a:fontRef>
         </p:style>
         <p:txBody>
-          <a:bodyPr rtlCol="0" anchor="ctr" wrap="square"/>
+          <a:bodyPr wrap="square" rtlCol="0" anchor="ctr"/>
           <a:lstStyle/>
           <a:p>
             <a:pPr algn="ctr">
@@ -3475,8 +3517,15 @@
               </a:defRPr>
             </a:pPr>
             <a:r>
-              <a:t>atom(x)</a:t>
-            </a:r>
+              <a:rPr lang="en-US" sz="1600" dirty="0" err="1">
+                <a:solidFill>
+                  <a:srgbClr val="111827"/>
+                </a:solidFill>
+                <a:latin typeface="Arial"/>
+              </a:rPr>
+              <a:t>AtomX</a:t>
+            </a:r>
+            <a:endParaRPr dirty="0"/>
           </a:p>
         </p:txBody>
       </p:sp>
@@ -3818,7 +3867,7 @@
           </a:fontRef>
         </p:style>
         <p:txBody>
-          <a:bodyPr rtlCol="0" anchor="ctr" wrap="square"/>
+          <a:bodyPr wrap="square" rtlCol="0" anchor="ctr"/>
           <a:lstStyle/>
           <a:p>
             <a:pPr algn="ctr">
@@ -3875,7 +3924,7 @@
           </a:fontRef>
         </p:style>
         <p:txBody>
-          <a:bodyPr rtlCol="0" anchor="ctr" wrap="square"/>
+          <a:bodyPr wrap="square" rtlCol="0" anchor="ctr"/>
           <a:lstStyle/>
           <a:p>
             <a:pPr algn="ctr">
@@ -3932,7 +3981,7 @@
           </a:fontRef>
         </p:style>
         <p:txBody>
-          <a:bodyPr rtlCol="0" anchor="ctr" wrap="square"/>
+          <a:bodyPr wrap="square" rtlCol="0" anchor="ctr"/>
           <a:lstStyle/>
           <a:p>
             <a:pPr algn="ctr">
@@ -3989,7 +4038,7 @@
           </a:fontRef>
         </p:style>
         <p:txBody>
-          <a:bodyPr rtlCol="0" anchor="ctr" wrap="square"/>
+          <a:bodyPr wrap="square" rtlCol="0" anchor="ctr"/>
           <a:lstStyle/>
           <a:p>
             <a:pPr algn="ctr">
@@ -4046,7 +4095,7 @@
           </a:fontRef>
         </p:style>
         <p:txBody>
-          <a:bodyPr rtlCol="0" anchor="ctr" wrap="square"/>
+          <a:bodyPr wrap="square" rtlCol="0" anchor="ctr"/>
           <a:lstStyle/>
           <a:p>
             <a:pPr algn="ctr">
@@ -4103,7 +4152,7 @@
           </a:fontRef>
         </p:style>
         <p:txBody>
-          <a:bodyPr rtlCol="0" anchor="ctr" wrap="square"/>
+          <a:bodyPr wrap="square" rtlCol="0" anchor="ctr"/>
           <a:lstStyle/>
           <a:p>
             <a:pPr algn="ctr">
@@ -4162,7 +4211,7 @@
           </a:fontRef>
         </p:style>
         <p:txBody>
-          <a:bodyPr rtlCol="0" anchor="ctr" wrap="square"/>
+          <a:bodyPr wrap="square" rtlCol="0" anchor="ctr"/>
           <a:lstStyle/>
           <a:p>
             <a:pPr algn="ctr">
@@ -4171,7 +4220,7 @@
               </a:spcAft>
             </a:pPr>
             <a:r>
-              <a:rPr b="1" sz="1100">
+              <a:rPr sz="1100" b="1">
                 <a:solidFill>
                   <a:srgbClr val="B91C1C"/>
                 </a:solidFill>
@@ -4179,7 +4228,7 @@
               <a:t>❖  OUR PROTOTYPE UI - </a:t>
             </a:r>
             <a:r>
-              <a:rPr b="1" u="sng" sz="1100">
+              <a:rPr sz="1100" b="1" u="sng">
                 <a:solidFill>
                   <a:srgbClr val="0D2F62"/>
                 </a:solidFill>
@@ -4190,7 +4239,7 @@
           </a:p>
           <a:p>
             <a:r>
-              <a:rPr b="1" sz="1100">
+              <a:rPr sz="1100" b="1">
                 <a:solidFill>
                   <a:srgbClr val="B91C1C"/>
                 </a:solidFill>
@@ -4198,7 +4247,7 @@
               <a:t>❖  OUR Repository - </a:t>
             </a:r>
             <a:r>
-              <a:rPr b="1" u="sng" sz="1100">
+              <a:rPr sz="1100" b="1" u="sng">
                 <a:solidFill>
                   <a:srgbClr val="0D2F62"/>
                 </a:solidFill>
@@ -4247,12 +4296,12 @@
           </a:fontRef>
         </p:style>
         <p:txBody>
-          <a:bodyPr rtlCol="0" anchor="ctr" wrap="square"/>
+          <a:bodyPr wrap="square" rtlCol="0" anchor="ctr"/>
           <a:lstStyle/>
           <a:p>
             <a:pPr algn="ctr"/>
             <a:r>
-              <a:rPr b="1" sz="1100">
+              <a:rPr sz="1100" b="1">
                 <a:solidFill>
                   <a:srgbClr val="1E3A8A"/>
                 </a:solidFill>
@@ -4280,7 +4329,7 @@
 </file>
 
 <file path=ppt/slides/slide3.xml><?xml version="1.0" encoding="utf-8"?>
-<p:sld xmlns:a="http://schemas.openxmlformats.org/drawingml/2006/main" xmlns:p="http://schemas.openxmlformats.org/presentationml/2006/main" xmlns:r="http://schemas.openxmlformats.org/officeDocument/2006/relationships">
+<p:sld xmlns:a="http://schemas.openxmlformats.org/drawingml/2006/main" xmlns:r="http://schemas.openxmlformats.org/officeDocument/2006/relationships" xmlns:p="http://schemas.openxmlformats.org/presentationml/2006/main">
   <p:cSld>
     <p:bg>
       <p:bgPr>
@@ -4296,7 +4345,14 @@
         <p:cNvGrpSpPr/>
         <p:nvPr/>
       </p:nvGrpSpPr>
-      <p:grpSpPr/>
+      <p:grpSpPr>
+        <a:xfrm>
+          <a:off x="0" y="0"/>
+          <a:ext cx="0" cy="0"/>
+          <a:chOff x="0" y="0"/>
+          <a:chExt cx="0" cy="0"/>
+        </a:xfrm>
+      </p:grpSpPr>
       <p:sp>
         <p:nvSpPr>
           <p:cNvPr id="2" name="Rounded Rectangle 1"/>
@@ -4335,7 +4391,7 @@
           </a:fontRef>
         </p:style>
         <p:txBody>
-          <a:bodyPr rtlCol="0" anchor="ctr" wrap="square"/>
+          <a:bodyPr wrap="square" rtlCol="0" anchor="ctr"/>
           <a:lstStyle/>
           <a:p>
             <a:pPr algn="ctr">
@@ -4347,8 +4403,15 @@
               </a:defRPr>
             </a:pPr>
             <a:r>
-              <a:t>atom(x)</a:t>
-            </a:r>
+              <a:rPr lang="en-US" sz="1600" dirty="0" err="1">
+                <a:solidFill>
+                  <a:srgbClr val="111827"/>
+                </a:solidFill>
+                <a:latin typeface="Arial"/>
+              </a:rPr>
+              <a:t>AtomX</a:t>
+            </a:r>
+            <a:endParaRPr dirty="0"/>
           </a:p>
         </p:txBody>
       </p:sp>
@@ -4522,7 +4585,7 @@
           </a:fontRef>
         </p:style>
         <p:txBody>
-          <a:bodyPr rtlCol="0" anchor="ctr" wrap="square"/>
+          <a:bodyPr wrap="square" rtlCol="0" anchor="ctr"/>
           <a:lstStyle/>
           <a:p>
             <a:pPr algn="ctr">
@@ -4589,7 +4652,7 @@
           </a:fontRef>
         </p:style>
         <p:txBody>
-          <a:bodyPr rtlCol="0" anchor="ctr" wrap="square"/>
+          <a:bodyPr wrap="square" rtlCol="0" anchor="ctr"/>
           <a:lstStyle/>
           <a:p>
             <a:pPr algn="ctr">
@@ -4656,7 +4719,7 @@
           </a:fontRef>
         </p:style>
         <p:txBody>
-          <a:bodyPr rtlCol="0" anchor="ctr" wrap="square"/>
+          <a:bodyPr wrap="square" rtlCol="0" anchor="ctr"/>
           <a:lstStyle/>
           <a:p>
             <a:pPr algn="ctr">
@@ -4723,7 +4786,7 @@
           </a:fontRef>
         </p:style>
         <p:txBody>
-          <a:bodyPr rtlCol="0" anchor="ctr" wrap="square"/>
+          <a:bodyPr wrap="square" rtlCol="0" anchor="ctr"/>
           <a:lstStyle/>
           <a:p>
             <a:pPr algn="ctr">
@@ -4814,7 +4877,7 @@
           </a:fontRef>
         </p:style>
         <p:txBody>
-          <a:bodyPr rtlCol="0" anchor="ctr" wrap="square"/>
+          <a:bodyPr wrap="square" rtlCol="0" anchor="ctr"/>
           <a:lstStyle/>
           <a:p>
             <a:pPr algn="ctr">
@@ -4885,7 +4948,7 @@
           </a:fontRef>
         </p:style>
         <p:txBody>
-          <a:bodyPr rtlCol="0" anchor="ctr" wrap="square"/>
+          <a:bodyPr wrap="square" rtlCol="0" anchor="ctr"/>
           <a:lstStyle/>
           <a:p>
             <a:pPr algn="ctr">
@@ -4952,7 +5015,7 @@
           </a:fontRef>
         </p:style>
         <p:txBody>
-          <a:bodyPr rtlCol="0" anchor="ctr" wrap="square"/>
+          <a:bodyPr wrap="square" rtlCol="0" anchor="ctr"/>
           <a:lstStyle/>
           <a:p>
             <a:pPr algn="ctr">
@@ -5019,7 +5082,7 @@
           </a:fontRef>
         </p:style>
         <p:txBody>
-          <a:bodyPr rtlCol="0" anchor="ctr" wrap="square"/>
+          <a:bodyPr wrap="square" rtlCol="0" anchor="ctr"/>
           <a:lstStyle/>
           <a:p>
             <a:pPr algn="ctr">
@@ -5057,7 +5120,7 @@
 </file>
 
 <file path=ppt/slides/slide4.xml><?xml version="1.0" encoding="utf-8"?>
-<p:sld xmlns:a="http://schemas.openxmlformats.org/drawingml/2006/main" xmlns:p="http://schemas.openxmlformats.org/presentationml/2006/main" xmlns:r="http://schemas.openxmlformats.org/officeDocument/2006/relationships">
+<p:sld xmlns:a="http://schemas.openxmlformats.org/drawingml/2006/main" xmlns:r="http://schemas.openxmlformats.org/officeDocument/2006/relationships" xmlns:p="http://schemas.openxmlformats.org/presentationml/2006/main">
   <p:cSld>
     <p:bg>
       <p:bgPr>
@@ -5073,7 +5136,14 @@
         <p:cNvGrpSpPr/>
         <p:nvPr/>
       </p:nvGrpSpPr>
-      <p:grpSpPr/>
+      <p:grpSpPr>
+        <a:xfrm>
+          <a:off x="0" y="0"/>
+          <a:ext cx="0" cy="0"/>
+          <a:chOff x="0" y="0"/>
+          <a:chExt cx="0" cy="0"/>
+        </a:xfrm>
+      </p:grpSpPr>
       <p:sp>
         <p:nvSpPr>
           <p:cNvPr id="2" name="Rounded Rectangle 1"/>
@@ -5112,7 +5182,7 @@
           </a:fontRef>
         </p:style>
         <p:txBody>
-          <a:bodyPr rtlCol="0" anchor="ctr" wrap="square"/>
+          <a:bodyPr wrap="square" rtlCol="0" anchor="ctr"/>
           <a:lstStyle/>
           <a:p>
             <a:pPr algn="ctr">
@@ -5124,8 +5194,15 @@
               </a:defRPr>
             </a:pPr>
             <a:r>
-              <a:t>atom(x)</a:t>
-            </a:r>
+              <a:rPr lang="en-US" sz="1600" dirty="0" err="1">
+                <a:solidFill>
+                  <a:srgbClr val="111827"/>
+                </a:solidFill>
+                <a:latin typeface="Arial"/>
+              </a:rPr>
+              <a:t>AtomX</a:t>
+            </a:r>
+            <a:endParaRPr dirty="0"/>
           </a:p>
         </p:txBody>
       </p:sp>
@@ -5355,7 +5432,7 @@
               </a:spcAft>
             </a:pPr>
             <a:r>
-              <a:rPr b="1" sz="1100">
+              <a:rPr sz="1100" b="1">
                 <a:solidFill>
                   <a:srgbClr val="6D28D9"/>
                 </a:solidFill>
@@ -5371,7 +5448,7 @@
               <a:t>LLM may misinterpret complex atmospheric queries → </a:t>
             </a:r>
             <a:r>
-              <a:rPr b="1" sz="1100">
+              <a:rPr sz="1100" b="1">
                 <a:solidFill>
                   <a:srgbClr val="111827"/>
                 </a:solidFill>
@@ -5394,7 +5471,7 @@
               </a:spcAft>
             </a:pPr>
             <a:r>
-              <a:rPr b="1" sz="1100">
+              <a:rPr sz="1100" b="1">
                 <a:solidFill>
                   <a:srgbClr val="6D28D9"/>
                 </a:solidFill>
@@ -5410,7 +5487,7 @@
               <a:t>Heavy cloud cover or limited sensors in certain sub-districts → </a:t>
             </a:r>
             <a:r>
-              <a:rPr b="1" sz="1100">
+              <a:rPr sz="1100" b="1">
                 <a:solidFill>
                   <a:srgbClr val="111827"/>
                 </a:solidFill>
@@ -5433,7 +5510,7 @@
               </a:spcAft>
             </a:pPr>
             <a:r>
-              <a:rPr b="1" sz="1100">
+              <a:rPr sz="1100" b="1">
                 <a:solidFill>
                   <a:srgbClr val="6D28D9"/>
                 </a:solidFill>
@@ -5449,7 +5526,7 @@
               <a:t>Real-time spatial-temporal dispersion maps require high resources → </a:t>
             </a:r>
             <a:r>
-              <a:rPr b="1" sz="1100">
+              <a:rPr sz="1100" b="1">
                 <a:solidFill>
                   <a:srgbClr val="111827"/>
                 </a:solidFill>
@@ -5472,7 +5549,7 @@
               </a:spcAft>
             </a:pPr>
             <a:r>
-              <a:rPr b="1" sz="1100">
+              <a:rPr sz="1100" b="1">
                 <a:solidFill>
                   <a:srgbClr val="6D28D9"/>
                 </a:solidFill>
@@ -5488,7 +5565,7 @@
               <a:t>Bureaucratic delay between forecast and enforcement → </a:t>
             </a:r>
             <a:r>
-              <a:rPr b="1" sz="1100">
+              <a:rPr sz="1100" b="1">
                 <a:solidFill>
                   <a:srgbClr val="111827"/>
                 </a:solidFill>
@@ -5551,7 +5628,7 @@
               </a:spcAft>
             </a:pPr>
             <a:r>
-              <a:rPr b="1" sz="1100">
+              <a:rPr sz="1100" b="1">
                 <a:solidFill>
                   <a:srgbClr val="6D28D9"/>
                 </a:solidFill>
@@ -5574,7 +5651,7 @@
               </a:spcAft>
             </a:pPr>
             <a:r>
-              <a:rPr b="1" sz="1100">
+              <a:rPr sz="1100" b="1">
                 <a:solidFill>
                   <a:srgbClr val="6D28D9"/>
                 </a:solidFill>
@@ -5597,7 +5674,7 @@
               </a:spcAft>
             </a:pPr>
             <a:r>
-              <a:rPr b="1" sz="1100">
+              <a:rPr sz="1100" b="1">
                 <a:solidFill>
                   <a:srgbClr val="6D28D9"/>
                 </a:solidFill>
@@ -5620,7 +5697,7 @@
               </a:spcAft>
             </a:pPr>
             <a:r>
-              <a:rPr b="1" sz="1100">
+              <a:rPr sz="1100" b="1">
                 <a:solidFill>
                   <a:srgbClr val="6D28D9"/>
                 </a:solidFill>
@@ -5647,7 +5724,7 @@
 </file>
 
 <file path=ppt/slides/slide5.xml><?xml version="1.0" encoding="utf-8"?>
-<p:sld xmlns:a="http://schemas.openxmlformats.org/drawingml/2006/main" xmlns:p="http://schemas.openxmlformats.org/presentationml/2006/main" xmlns:r="http://schemas.openxmlformats.org/officeDocument/2006/relationships">
+<p:sld xmlns:a="http://schemas.openxmlformats.org/drawingml/2006/main" xmlns:r="http://schemas.openxmlformats.org/officeDocument/2006/relationships" xmlns:p="http://schemas.openxmlformats.org/presentationml/2006/main">
   <p:cSld>
     <p:bg>
       <p:bgPr>
@@ -5663,7 +5740,14 @@
         <p:cNvGrpSpPr/>
         <p:nvPr/>
       </p:nvGrpSpPr>
-      <p:grpSpPr/>
+      <p:grpSpPr>
+        <a:xfrm>
+          <a:off x="0" y="0"/>
+          <a:ext cx="0" cy="0"/>
+          <a:chOff x="0" y="0"/>
+          <a:chExt cx="0" cy="0"/>
+        </a:xfrm>
+      </p:grpSpPr>
       <p:sp>
         <p:nvSpPr>
           <p:cNvPr id="2" name="Rounded Rectangle 1"/>
@@ -5702,7 +5786,7 @@
           </a:fontRef>
         </p:style>
         <p:txBody>
-          <a:bodyPr rtlCol="0" anchor="ctr" wrap="square"/>
+          <a:bodyPr wrap="square" rtlCol="0" anchor="ctr"/>
           <a:lstStyle/>
           <a:p>
             <a:pPr algn="ctr">
@@ -5714,8 +5798,15 @@
               </a:defRPr>
             </a:pPr>
             <a:r>
-              <a:t>atom(x)</a:t>
-            </a:r>
+              <a:rPr lang="en-US" sz="1600" dirty="0" err="1">
+                <a:solidFill>
+                  <a:srgbClr val="111827"/>
+                </a:solidFill>
+                <a:latin typeface="Arial"/>
+              </a:rPr>
+              <a:t>AtomX</a:t>
+            </a:r>
+            <a:endParaRPr dirty="0"/>
           </a:p>
         </p:txBody>
       </p:sp>
@@ -5927,7 +6018,7 @@
               </a:spcAft>
             </a:pPr>
             <a:r>
-              <a:rPr b="1" sz="1150">
+              <a:rPr sz="1150" b="1">
                 <a:solidFill>
                   <a:srgbClr val="6D28D9"/>
                 </a:solidFill>
@@ -5950,7 +6041,7 @@
               </a:spcAft>
             </a:pPr>
             <a:r>
-              <a:rPr b="1" sz="1150">
+              <a:rPr sz="1150" b="1">
                 <a:solidFill>
                   <a:srgbClr val="6D28D9"/>
                 </a:solidFill>
@@ -5973,7 +6064,7 @@
               </a:spcAft>
             </a:pPr>
             <a:r>
-              <a:rPr b="1" sz="1150">
+              <a:rPr sz="1150" b="1">
                 <a:solidFill>
                   <a:srgbClr val="6D28D9"/>
                 </a:solidFill>
@@ -6079,7 +6170,7 @@
 </file>
 
 <file path=ppt/slides/slide6.xml><?xml version="1.0" encoding="utf-8"?>
-<p:sld xmlns:a="http://schemas.openxmlformats.org/drawingml/2006/main" xmlns:p="http://schemas.openxmlformats.org/presentationml/2006/main" xmlns:r="http://schemas.openxmlformats.org/officeDocument/2006/relationships">
+<p:sld xmlns:a="http://schemas.openxmlformats.org/drawingml/2006/main" xmlns:r="http://schemas.openxmlformats.org/officeDocument/2006/relationships" xmlns:p="http://schemas.openxmlformats.org/presentationml/2006/main">
   <p:cSld>
     <p:bg>
       <p:bgPr>
@@ -6095,7 +6186,14 @@
         <p:cNvGrpSpPr/>
         <p:nvPr/>
       </p:nvGrpSpPr>
-      <p:grpSpPr/>
+      <p:grpSpPr>
+        <a:xfrm>
+          <a:off x="0" y="0"/>
+          <a:ext cx="0" cy="0"/>
+          <a:chOff x="0" y="0"/>
+          <a:chExt cx="0" cy="0"/>
+        </a:xfrm>
+      </p:grpSpPr>
       <p:sp>
         <p:nvSpPr>
           <p:cNvPr id="2" name="Rounded Rectangle 1"/>
@@ -6134,7 +6232,7 @@
           </a:fontRef>
         </p:style>
         <p:txBody>
-          <a:bodyPr rtlCol="0" anchor="ctr" wrap="square"/>
+          <a:bodyPr wrap="square" rtlCol="0" anchor="ctr"/>
           <a:lstStyle/>
           <a:p>
             <a:pPr algn="ctr">
@@ -6146,8 +6244,15 @@
               </a:defRPr>
             </a:pPr>
             <a:r>
-              <a:t>atom(x)</a:t>
-            </a:r>
+              <a:rPr lang="en-US" sz="1600">
+                <a:solidFill>
+                  <a:srgbClr val="111827"/>
+                </a:solidFill>
+                <a:latin typeface="Arial"/>
+              </a:rPr>
+              <a:t>AtomX</a:t>
+            </a:r>
+            <a:endParaRPr dirty="0"/>
           </a:p>
         </p:txBody>
       </p:sp>
@@ -6321,7 +6426,7 @@
           </a:fontRef>
         </p:style>
         <p:txBody>
-          <a:bodyPr rtlCol="0" anchor="ctr" wrap="square" lIns="320040" tIns="274320" rIns="320040" bIns="274320"/>
+          <a:bodyPr wrap="square" lIns="320040" tIns="274320" rIns="320040" bIns="274320" rtlCol="0" anchor="ctr"/>
           <a:lstStyle/>
           <a:p>
             <a:pPr algn="ctr">
@@ -6330,7 +6435,7 @@
               </a:spcAft>
             </a:pPr>
             <a:r>
-              <a:rPr b="1" sz="1150">
+              <a:rPr sz="1150" b="1">
                 <a:solidFill>
                   <a:srgbClr val="111827"/>
                 </a:solidFill>
@@ -6338,7 +6443,7 @@
               <a:t>1.  SAFAR: Air Quality and Weather Forecasting And Research </a:t>
             </a:r>
             <a:r>
-              <a:rPr b="0" sz="1100">
+              <a:rPr sz="1100" b="0">
                 <a:solidFill>
                   <a:srgbClr val="111827"/>
                 </a:solidFill>
@@ -6346,7 +6451,7 @@
               <a:t>Authors: Gufran Beig, S. Parkhi, et al. (2015) </a:t>
             </a:r>
             <a:r>
-              <a:rPr b="1" sz="1100">
+              <a:rPr sz="1100" b="1">
                 <a:solidFill>
                   <a:srgbClr val="111827"/>
                 </a:solidFill>
@@ -6354,7 +6459,7 @@
               <a:t>Summary: </a:t>
             </a:r>
             <a:r>
-              <a:rPr b="0" sz="1050">
+              <a:rPr sz="1050" b="0">
                 <a:solidFill>
                   <a:srgbClr val="111827"/>
                 </a:solidFill>
@@ -6369,7 +6474,7 @@
               </a:spcAft>
             </a:pPr>
             <a:r>
-              <a:rPr b="1" sz="1150">
+              <a:rPr sz="1150" b="1">
                 <a:solidFill>
                   <a:srgbClr val="111827"/>
                 </a:solidFill>
@@ -6377,7 +6482,7 @@
               <a:t>2.  NASA FIRMS: Active Fire Detection &amp; Transboundary Smoke Attribution </a:t>
             </a:r>
             <a:r>
-              <a:rPr b="0" sz="1100">
+              <a:rPr sz="1100" b="0">
                 <a:solidFill>
                   <a:srgbClr val="111827"/>
                 </a:solidFill>
@@ -6385,7 +6490,7 @@
               <a:t>Authors: Wilfrid Schroeder, Louis Giglio, et al. (2014) </a:t>
             </a:r>
             <a:r>
-              <a:rPr b="1" sz="1100">
+              <a:rPr sz="1100" b="1">
                 <a:solidFill>
                   <a:srgbClr val="111827"/>
                 </a:solidFill>
@@ -6393,7 +6498,7 @@
               <a:t>Summary: </a:t>
             </a:r>
             <a:r>
-              <a:rPr b="0" sz="1050">
+              <a:rPr sz="1050" b="0">
                 <a:solidFill>
                   <a:srgbClr val="111827"/>
                 </a:solidFill>
@@ -6408,7 +6513,7 @@
               </a:spcAft>
             </a:pPr>
             <a:r>
-              <a:rPr b="1" sz="1150">
+              <a:rPr sz="1150" b="1">
                 <a:solidFill>
                   <a:srgbClr val="111827"/>
                 </a:solidFill>
@@ -6416,7 +6521,7 @@
               <a:t>3.  Graded Response Action Plan (GRAP) Guidelines </a:t>
             </a:r>
             <a:r>
-              <a:rPr b="0" sz="1100">
+              <a:rPr sz="1100" b="0">
                 <a:solidFill>
                   <a:srgbClr val="111827"/>
                 </a:solidFill>
@@ -6424,7 +6529,7 @@
               <a:t>Authors: Commission for Air Quality Management in NCR &amp; Adjoining Areas (CAQM, 2023) </a:t>
             </a:r>
             <a:r>
-              <a:rPr b="1" sz="1100">
+              <a:rPr sz="1100" b="1">
                 <a:solidFill>
                   <a:srgbClr val="111827"/>
                 </a:solidFill>
@@ -6432,7 +6537,7 @@
               <a:t>Summary: </a:t>
             </a:r>
             <a:r>
-              <a:rPr b="0" sz="1050">
+              <a:rPr sz="1050" b="0">
                 <a:solidFill>
                   <a:srgbClr val="111827"/>
                 </a:solidFill>
@@ -6447,7 +6552,7 @@
               </a:spcAft>
             </a:pPr>
             <a:r>
-              <a:rPr b="1" sz="1150">
+              <a:rPr sz="1150" b="1">
                 <a:solidFill>
                   <a:srgbClr val="111827"/>
                 </a:solidFill>
@@ -6455,7 +6560,7 @@
               <a:t>4.  Atmospheric Boundary Layer Dynamics &amp; Inversion Trapping </a:t>
             </a:r>
             <a:r>
-              <a:rPr b="0" sz="1100">
+              <a:rPr sz="1100" b="0">
                 <a:solidFill>
                   <a:srgbClr val="111827"/>
                 </a:solidFill>
@@ -6463,7 +6568,7 @@
               <a:t>Authors: Roland B. Stull (1988/2021) </a:t>
             </a:r>
             <a:r>
-              <a:rPr b="1" sz="1100">
+              <a:rPr sz="1100" b="1">
                 <a:solidFill>
                   <a:srgbClr val="111827"/>
                 </a:solidFill>
@@ -6471,7 +6576,7 @@
               <a:t>Summary: </a:t>
             </a:r>
             <a:r>
-              <a:rPr b="0" sz="1050">
+              <a:rPr sz="1050" b="0">
                 <a:solidFill>
                   <a:srgbClr val="111827"/>
                 </a:solidFill>

</xml_diff>

<commit_message>
feat(presentation): embed real new front-facing interface screenshots into SIH idea submission deck
</commit_message>
<xml_diff>
--- a/VayuCoupler_SIH_AtomX_Idea_Submission.pptx
+++ b/VayuCoupler_SIH_AtomX_Idea_Submission.pptx
@@ -3775,7 +3775,7 @@
         <p:spPr>
           <a:xfrm>
             <a:off x="6172200" y="1051560"/>
-            <a:ext cx="2331720" cy="4451465"/>
+            <a:ext cx="2331720" cy="4557453"/>
           </a:xfrm>
           <a:prstGeom prst="rect">
             <a:avLst/>
@@ -4769,7 +4769,7 @@
         <p:spPr>
           <a:xfrm>
             <a:off x="3063240" y="1078992"/>
-            <a:ext cx="5943600" cy="4754880"/>
+            <a:ext cx="5943600" cy="4041648"/>
           </a:xfrm>
           <a:prstGeom prst="rect">
             <a:avLst/>

</xml_diff>

<commit_message>
feat(presentation): replace slide 3 with end-to-end app interaction model and technical architecture
</commit_message>
<xml_diff>
--- a/VayuCoupler_SIH_AtomX_Idea_Submission.pptx
+++ b/VayuCoupler_SIH_AtomX_Idea_Submission.pptx
@@ -4383,7 +4383,7 @@
               </a:defRPr>
             </a:pPr>
             <a:r>
-              <a:t>TECHNICAL APPROACH</a:t>
+              <a:t>TECHNICAL APPROACH &amp; APP INTERACTION MODEL</a:t>
             </a:r>
           </a:p>
         </p:txBody>
@@ -4484,277 +4484,9 @@
           </a:p>
         </p:txBody>
       </p:sp>
-      <p:sp>
-        <p:nvSpPr>
-          <p:cNvPr id="7" name="Rounded Rectangle 6"/>
-          <p:cNvSpPr/>
-          <p:nvPr/>
-        </p:nvSpPr>
-        <p:spPr>
-          <a:xfrm>
-            <a:off x="457200" y="1097280"/>
-            <a:ext cx="2468880" cy="1143000"/>
-          </a:xfrm>
-          <a:prstGeom prst="roundRect">
-            <a:avLst/>
-          </a:prstGeom>
-          <a:solidFill>
-            <a:srgbClr val="EFF6FF"/>
-          </a:solidFill>
-          <a:ln w="19050">
-            <a:solidFill>
-              <a:srgbClr val="3B82F6"/>
-            </a:solidFill>
-          </a:ln>
-        </p:spPr>
-        <p:style>
-          <a:lnRef idx="1">
-            <a:schemeClr val="accent1"/>
-          </a:lnRef>
-          <a:fillRef idx="3">
-            <a:schemeClr val="accent1"/>
-          </a:fillRef>
-          <a:effectRef idx="2">
-            <a:schemeClr val="accent1"/>
-          </a:effectRef>
-          <a:fontRef idx="minor">
-            <a:schemeClr val="lt1"/>
-          </a:fontRef>
-        </p:style>
-        <p:txBody>
-          <a:bodyPr rtlCol="0" anchor="ctr" wrap="square"/>
-          <a:lstStyle/>
-          <a:p>
-            <a:pPr algn="ctr">
-              <a:defRPr sz="1050" b="1">
-                <a:solidFill>
-                  <a:srgbClr val="1E3A8A"/>
-                </a:solidFill>
-                <a:latin typeface="Arial"/>
-              </a:defRPr>
-            </a:pPr>
-            <a:r>
-              <a:t>using Interactive Maps</a:t>
-            </a:r>
-            <a:br/>
-            <a:r>
-              <a:t>to Enable region-based</a:t>
-            </a:r>
-            <a:br/>
-            <a:r>
-              <a:t>search and intuitive</a:t>
-            </a:r>
-            <a:br/>
-            <a:r>
-              <a:t>data discovery.</a:t>
-            </a:r>
-          </a:p>
-        </p:txBody>
-      </p:sp>
-      <p:sp>
-        <p:nvSpPr>
-          <p:cNvPr id="8" name="Rounded Rectangle 7"/>
-          <p:cNvSpPr/>
-          <p:nvPr/>
-        </p:nvSpPr>
-        <p:spPr>
-          <a:xfrm>
-            <a:off x="457200" y="2404872"/>
-            <a:ext cx="2468880" cy="1143000"/>
-          </a:xfrm>
-          <a:prstGeom prst="roundRect">
-            <a:avLst/>
-          </a:prstGeom>
-          <a:solidFill>
-            <a:srgbClr val="EFF6FF"/>
-          </a:solidFill>
-          <a:ln w="19050">
-            <a:solidFill>
-              <a:srgbClr val="3B82F6"/>
-            </a:solidFill>
-          </a:ln>
-        </p:spPr>
-        <p:style>
-          <a:lnRef idx="1">
-            <a:schemeClr val="accent1"/>
-          </a:lnRef>
-          <a:fillRef idx="3">
-            <a:schemeClr val="accent1"/>
-          </a:fillRef>
-          <a:effectRef idx="2">
-            <a:schemeClr val="accent1"/>
-          </a:effectRef>
-          <a:fontRef idx="minor">
-            <a:schemeClr val="lt1"/>
-          </a:fontRef>
-        </p:style>
-        <p:txBody>
-          <a:bodyPr rtlCol="0" anchor="ctr" wrap="square"/>
-          <a:lstStyle/>
-          <a:p>
-            <a:pPr algn="ctr">
-              <a:defRPr sz="1050" b="1">
-                <a:solidFill>
-                  <a:srgbClr val="1E3A8A"/>
-                </a:solidFill>
-                <a:latin typeface="Arial"/>
-              </a:defRPr>
-            </a:pPr>
-            <a:r>
-              <a:t>Converts multi-source feeds</a:t>
-            </a:r>
-            <a:br/>
-            <a:r>
-              <a:t>into structured databases,</a:t>
-            </a:r>
-            <a:br/>
-            <a:r>
-              <a:t>simplifying access and enabling</a:t>
-            </a:r>
-            <a:br/>
-            <a:r>
-              <a:t>fast, queryable insights.</a:t>
-            </a:r>
-          </a:p>
-        </p:txBody>
-      </p:sp>
-      <p:sp>
-        <p:nvSpPr>
-          <p:cNvPr id="9" name="Rounded Rectangle 8"/>
-          <p:cNvSpPr/>
-          <p:nvPr/>
-        </p:nvSpPr>
-        <p:spPr>
-          <a:xfrm>
-            <a:off x="457200" y="3712464"/>
-            <a:ext cx="2468880" cy="1143000"/>
-          </a:xfrm>
-          <a:prstGeom prst="roundRect">
-            <a:avLst/>
-          </a:prstGeom>
-          <a:solidFill>
-            <a:srgbClr val="EFF6FF"/>
-          </a:solidFill>
-          <a:ln w="19050">
-            <a:solidFill>
-              <a:srgbClr val="3B82F6"/>
-            </a:solidFill>
-          </a:ln>
-        </p:spPr>
-        <p:style>
-          <a:lnRef idx="1">
-            <a:schemeClr val="accent1"/>
-          </a:lnRef>
-          <a:fillRef idx="3">
-            <a:schemeClr val="accent1"/>
-          </a:fillRef>
-          <a:effectRef idx="2">
-            <a:schemeClr val="accent1"/>
-          </a:effectRef>
-          <a:fontRef idx="minor">
-            <a:schemeClr val="lt1"/>
-          </a:fontRef>
-        </p:style>
-        <p:txBody>
-          <a:bodyPr rtlCol="0" anchor="ctr" wrap="square"/>
-          <a:lstStyle/>
-          <a:p>
-            <a:pPr algn="ctr">
-              <a:defRPr sz="1050" b="1">
-                <a:solidFill>
-                  <a:srgbClr val="1E3A8A"/>
-                </a:solidFill>
-                <a:latin typeface="Arial"/>
-              </a:defRPr>
-            </a:pPr>
-            <a:r>
-              <a:t>Answering Queries on</a:t>
-            </a:r>
-            <a:br/>
-            <a:r>
-              <a:t>Features like PM2.5, PM10,</a:t>
-            </a:r>
-            <a:br/>
-            <a:r>
-              <a:t>Ventilation Index (VI), PBLH,</a:t>
-            </a:r>
-            <a:br/>
-            <a:r>
-              <a:t>Thermal Inversion (ΔT)</a:t>
-            </a:r>
-          </a:p>
-        </p:txBody>
-      </p:sp>
-      <p:sp>
-        <p:nvSpPr>
-          <p:cNvPr id="10" name="Rounded Rectangle 9"/>
-          <p:cNvSpPr/>
-          <p:nvPr/>
-        </p:nvSpPr>
-        <p:spPr>
-          <a:xfrm>
-            <a:off x="457200" y="5020056"/>
-            <a:ext cx="2468880" cy="1143000"/>
-          </a:xfrm>
-          <a:prstGeom prst="roundRect">
-            <a:avLst/>
-          </a:prstGeom>
-          <a:solidFill>
-            <a:srgbClr val="EFF6FF"/>
-          </a:solidFill>
-          <a:ln w="19050">
-            <a:solidFill>
-              <a:srgbClr val="3B82F6"/>
-            </a:solidFill>
-          </a:ln>
-        </p:spPr>
-        <p:style>
-          <a:lnRef idx="1">
-            <a:schemeClr val="accent1"/>
-          </a:lnRef>
-          <a:fillRef idx="3">
-            <a:schemeClr val="accent1"/>
-          </a:fillRef>
-          <a:effectRef idx="2">
-            <a:schemeClr val="accent1"/>
-          </a:effectRef>
-          <a:fontRef idx="minor">
-            <a:schemeClr val="lt1"/>
-          </a:fontRef>
-        </p:style>
-        <p:txBody>
-          <a:bodyPr rtlCol="0" anchor="ctr" wrap="square"/>
-          <a:lstStyle/>
-          <a:p>
-            <a:pPr algn="ctr">
-              <a:defRPr sz="1050" b="1">
-                <a:solidFill>
-                  <a:srgbClr val="1E3A8A"/>
-                </a:solidFill>
-                <a:latin typeface="Arial"/>
-              </a:defRPr>
-            </a:pPr>
-            <a:r>
-              <a:t>Using Figma To Designing</a:t>
-            </a:r>
-            <a:br/>
-            <a:r>
-              <a:t>Our website</a:t>
-            </a:r>
-            <a:br/>
-            <a:r>
-              <a:t>Using React.Js / HTML5 for</a:t>
-            </a:r>
-            <a:br/>
-            <a:r>
-              <a:t>building interface of website</a:t>
-            </a:r>
-          </a:p>
-        </p:txBody>
-      </p:sp>
       <p:pic>
         <p:nvPicPr>
-          <p:cNvPr id="11" name="Picture 10" descr="technical_center_composition.png"/>
+          <p:cNvPr id="7" name="Picture 6" descr="app_interaction_model.png"/>
           <p:cNvPicPr>
             <a:picLocks noChangeAspect="1"/>
           </p:cNvPicPr>
@@ -4768,286 +4500,14 @@
         </p:blipFill>
         <p:spPr>
           <a:xfrm>
-            <a:off x="3063240" y="1078992"/>
-            <a:ext cx="5943600" cy="4041648"/>
+            <a:off x="475488" y="1051560"/>
+            <a:ext cx="11247120" cy="5349240"/>
           </a:xfrm>
           <a:prstGeom prst="rect">
             <a:avLst/>
           </a:prstGeom>
         </p:spPr>
       </p:pic>
-      <p:sp>
-        <p:nvSpPr>
-          <p:cNvPr id="12" name="Rounded Rectangle 11"/>
-          <p:cNvSpPr/>
-          <p:nvPr/>
-        </p:nvSpPr>
-        <p:spPr>
-          <a:xfrm>
-            <a:off x="9235440" y="1097280"/>
-            <a:ext cx="2468880" cy="1143000"/>
-          </a:xfrm>
-          <a:prstGeom prst="roundRect">
-            <a:avLst/>
-          </a:prstGeom>
-          <a:solidFill>
-            <a:srgbClr val="EFF6FF"/>
-          </a:solidFill>
-          <a:ln w="19050">
-            <a:solidFill>
-              <a:srgbClr val="3B82F6"/>
-            </a:solidFill>
-          </a:ln>
-        </p:spPr>
-        <p:style>
-          <a:lnRef idx="1">
-            <a:schemeClr val="accent1"/>
-          </a:lnRef>
-          <a:fillRef idx="3">
-            <a:schemeClr val="accent1"/>
-          </a:fillRef>
-          <a:effectRef idx="2">
-            <a:schemeClr val="accent1"/>
-          </a:effectRef>
-          <a:fontRef idx="minor">
-            <a:schemeClr val="lt1"/>
-          </a:fontRef>
-        </p:style>
-        <p:txBody>
-          <a:bodyPr rtlCol="0" anchor="ctr" wrap="square"/>
-          <a:lstStyle/>
-          <a:p>
-            <a:pPr algn="ctr">
-              <a:defRPr sz="1050" b="1">
-                <a:solidFill>
-                  <a:srgbClr val="1E3A8A"/>
-                </a:solidFill>
-                <a:latin typeface="Arial"/>
-              </a:defRPr>
-            </a:pPr>
-            <a:r>
-              <a:t>using LLM + RAG</a:t>
-            </a:r>
-            <a:br/>
-            <a:r>
-              <a:t>Pipelines</a:t>
-            </a:r>
-            <a:br/>
-            <a:r>
-              <a:t>to Allow citizens to ask</a:t>
-            </a:r>
-            <a:br/>
-            <a:r>
-              <a:t>questions in natural</a:t>
-            </a:r>
-            <a:br/>
-            <a:r>
-              <a:t>language to VayuAI.</a:t>
-            </a:r>
-          </a:p>
-        </p:txBody>
-      </p:sp>
-      <p:sp>
-        <p:nvSpPr>
-          <p:cNvPr id="13" name="Rounded Rectangle 12"/>
-          <p:cNvSpPr/>
-          <p:nvPr/>
-        </p:nvSpPr>
-        <p:spPr>
-          <a:xfrm>
-            <a:off x="9235440" y="2404872"/>
-            <a:ext cx="2468880" cy="1143000"/>
-          </a:xfrm>
-          <a:prstGeom prst="roundRect">
-            <a:avLst/>
-          </a:prstGeom>
-          <a:solidFill>
-            <a:srgbClr val="EFF6FF"/>
-          </a:solidFill>
-          <a:ln w="19050">
-            <a:solidFill>
-              <a:srgbClr val="3B82F6"/>
-            </a:solidFill>
-          </a:ln>
-        </p:spPr>
-        <p:style>
-          <a:lnRef idx="1">
-            <a:schemeClr val="accent1"/>
-          </a:lnRef>
-          <a:fillRef idx="3">
-            <a:schemeClr val="accent1"/>
-          </a:fillRef>
-          <a:effectRef idx="2">
-            <a:schemeClr val="accent1"/>
-          </a:effectRef>
-          <a:fontRef idx="minor">
-            <a:schemeClr val="lt1"/>
-          </a:fontRef>
-        </p:style>
-        <p:txBody>
-          <a:bodyPr rtlCol="0" anchor="ctr" wrap="square"/>
-          <a:lstStyle/>
-          <a:p>
-            <a:pPr algn="ctr">
-              <a:defRPr sz="1050" b="1">
-                <a:solidFill>
-                  <a:srgbClr val="1E3A8A"/>
-                </a:solidFill>
-                <a:latin typeface="Arial"/>
-              </a:defRPr>
-            </a:pPr>
-            <a:r>
-              <a:t>Safe Commute Engine</a:t>
-            </a:r>
-            <a:br/>
-            <a:r>
-              <a:t>Calculates Cleanest Route</a:t>
-            </a:r>
-            <a:br/>
-            <a:r>
-              <a:t>→ Cuts toxic particulate</a:t>
-            </a:r>
-            <a:br/>
-            <a:r>
-              <a:t>inhalation by 35%–48%.</a:t>
-            </a:r>
-          </a:p>
-        </p:txBody>
-      </p:sp>
-      <p:sp>
-        <p:nvSpPr>
-          <p:cNvPr id="14" name="Rounded Rectangle 13"/>
-          <p:cNvSpPr/>
-          <p:nvPr/>
-        </p:nvSpPr>
-        <p:spPr>
-          <a:xfrm>
-            <a:off x="9235440" y="3712464"/>
-            <a:ext cx="2468880" cy="1143000"/>
-          </a:xfrm>
-          <a:prstGeom prst="roundRect">
-            <a:avLst/>
-          </a:prstGeom>
-          <a:solidFill>
-            <a:srgbClr val="EFF6FF"/>
-          </a:solidFill>
-          <a:ln w="19050">
-            <a:solidFill>
-              <a:srgbClr val="3B82F6"/>
-            </a:solidFill>
-          </a:ln>
-        </p:spPr>
-        <p:style>
-          <a:lnRef idx="1">
-            <a:schemeClr val="accent1"/>
-          </a:lnRef>
-          <a:fillRef idx="3">
-            <a:schemeClr val="accent1"/>
-          </a:fillRef>
-          <a:effectRef idx="2">
-            <a:schemeClr val="accent1"/>
-          </a:effectRef>
-          <a:fontRef idx="minor">
-            <a:schemeClr val="lt1"/>
-          </a:fontRef>
-        </p:style>
-        <p:txBody>
-          <a:bodyPr rtlCol="0" anchor="ctr" wrap="square"/>
-          <a:lstStyle/>
-          <a:p>
-            <a:pPr algn="ctr">
-              <a:defRPr sz="1050" b="1">
-                <a:solidFill>
-                  <a:srgbClr val="1E3A8A"/>
-                </a:solidFill>
-                <a:latin typeface="Arial"/>
-              </a:defRPr>
-            </a:pPr>
-            <a:r>
-              <a:t>Using Cloud Deployment</a:t>
-            </a:r>
-            <a:br/>
-            <a:r>
-              <a:t>Deploying on Vercel &amp; Render</a:t>
-            </a:r>
-            <a:br/>
-            <a:r>
-              <a:t>for scalability, reliability +</a:t>
-            </a:r>
-            <a:br/>
-            <a:r>
-              <a:t>100% offline standalone mode.</a:t>
-            </a:r>
-          </a:p>
-        </p:txBody>
-      </p:sp>
-      <p:sp>
-        <p:nvSpPr>
-          <p:cNvPr id="15" name="Rounded Rectangle 14"/>
-          <p:cNvSpPr/>
-          <p:nvPr/>
-        </p:nvSpPr>
-        <p:spPr>
-          <a:xfrm>
-            <a:off x="9235440" y="5020056"/>
-            <a:ext cx="2468880" cy="1143000"/>
-          </a:xfrm>
-          <a:prstGeom prst="roundRect">
-            <a:avLst/>
-          </a:prstGeom>
-          <a:solidFill>
-            <a:srgbClr val="EFF6FF"/>
-          </a:solidFill>
-          <a:ln w="19050">
-            <a:solidFill>
-              <a:srgbClr val="3B82F6"/>
-            </a:solidFill>
-          </a:ln>
-        </p:spPr>
-        <p:style>
-          <a:lnRef idx="1">
-            <a:schemeClr val="accent1"/>
-          </a:lnRef>
-          <a:fillRef idx="3">
-            <a:schemeClr val="accent1"/>
-          </a:fillRef>
-          <a:effectRef idx="2">
-            <a:schemeClr val="accent1"/>
-          </a:effectRef>
-          <a:fontRef idx="minor">
-            <a:schemeClr val="lt1"/>
-          </a:fontRef>
-        </p:style>
-        <p:txBody>
-          <a:bodyPr rtlCol="0" anchor="ctr" wrap="square"/>
-          <a:lstStyle/>
-          <a:p>
-            <a:pPr algn="ctr">
-              <a:defRPr sz="1050" b="1">
-                <a:solidFill>
-                  <a:srgbClr val="1E3A8A"/>
-                </a:solidFill>
-                <a:latin typeface="Arial"/>
-              </a:defRPr>
-            </a:pPr>
-            <a:r>
-              <a:t>Google Weather Integration</a:t>
-            </a:r>
-            <a:br/>
-            <a:r>
-              <a:t>Real-time temp, rain chance,</a:t>
-            </a:r>
-            <a:br/>
-            <a:r>
-              <a:t>wind speed, humidity &amp; UV</a:t>
-            </a:r>
-            <a:br/>
-            <a:r>
-              <a:t>directly beside AQI.</a:t>
-            </a:r>
-          </a:p>
-        </p:txBody>
-      </p:sp>
     </p:spTree>
   </p:cSld>
   <p:clrMapOvr>

</xml_diff>